<commit_message>
Remove narration and presentation speaker notes
</commit_message>
<xml_diff>
--- a/docs/Prism-Introduction.pptx
+++ b/docs/Prism-Introduction.pptx
@@ -1,697 +1,17 @@
 
 <file path=ppt/presentation.xml><?xml version="1.0" encoding="utf-8"?>
-<p:presentation xmlns:p="http://schemas.openxmlformats.org/presentationml/2006/main">
-  <p:sldMasterIdLst>
-    <p:sldMasterId xmlns:r="http://schemas.openxmlformats.org/officeDocument/2006/relationships" id="2147483648" r:id="Rcc1a760a4666491c"/>
-  </p:sldMasterIdLst>
-  <p:notesMasterIdLst>
-    <p:notesMasterId xmlns:r="http://schemas.openxmlformats.org/officeDocument/2006/relationships" r:id="R6865996375464235"/>
-  </p:notesMasterIdLst>
-  <p:sldIdLst>
-    <p:sldId xmlns:r="http://schemas.openxmlformats.org/officeDocument/2006/relationships" id="256" r:id="Rcd3cad99104e4dd7"/>
-    <p:sldId xmlns:r="http://schemas.openxmlformats.org/officeDocument/2006/relationships" id="257" r:id="Rd2c363007ceb4775"/>
-    <p:sldId xmlns:r="http://schemas.openxmlformats.org/officeDocument/2006/relationships" id="258" r:id="R301696bd72ec4f11"/>
-  </p:sldIdLst>
-  <p:sldSz cx="12192000" cy="6858000"/>
-  <p:notesSz cx="6858000" cy="9144000"/>
-</p:presentation>
-</file>
-
-<file path=ppt/notesMasters/notesMaster1.xml><?xml version="1.0" encoding="utf-8"?>
-<p:notesMaster xmlns:p="http://schemas.openxmlformats.org/presentationml/2006/main">
-  <p:cSld>
-    <p:bg>
-      <p:bgRef idx="1001">
-        <a:schemeClr xmlns:a="http://schemas.openxmlformats.org/drawingml/2006/main" val="bg1"/>
-      </p:bgRef>
-    </p:bg>
-    <p:spTree>
-      <p:nvGrpSpPr>
-        <p:cNvPr id="1" name=""/>
-        <p:cNvGrpSpPr/>
-        <p:nvPr/>
-      </p:nvGrpSpPr>
-      <p:grpSpPr>
-        <a:xfrm xmlns:a="http://schemas.openxmlformats.org/drawingml/2006/main"/>
-      </p:grpSpPr>
-      <p:sp>
-        <p:nvSpPr>
-          <p:cNvPr id="2" name="Header Placeholder"/>
-          <p:cNvSpPr/>
-          <p:nvPr>
-            <p:ph type="hdr" sz="quarter"/>
-          </p:nvPr>
-        </p:nvSpPr>
-        <p:spPr>
-          <a:prstGeom xmlns:a="http://schemas.openxmlformats.org/drawingml/2006/main" prst="rect">
-            <a:avLst/>
-          </a:prstGeom>
-        </p:spPr>
-        <p:txBody>
-          <a:bodyPr xmlns:a="http://schemas.openxmlformats.org/drawingml/2006/main"/>
-          <a:lstStyle xmlns:a="http://schemas.openxmlformats.org/drawingml/2006/main"/>
-          <a:p xmlns:a="http://schemas.openxmlformats.org/drawingml/2006/main"/>
-        </p:txBody>
-      </p:sp>
-      <p:sp>
-        <p:nvSpPr>
-          <p:cNvPr id="3" name="Date Placeholder"/>
-          <p:cNvSpPr/>
-          <p:nvPr>
-            <p:ph type="dt" sz="quarter" idx="1"/>
-          </p:nvPr>
-        </p:nvSpPr>
-        <p:spPr>
-          <a:prstGeom xmlns:a="http://schemas.openxmlformats.org/drawingml/2006/main" prst="rect">
-            <a:avLst/>
-          </a:prstGeom>
-        </p:spPr>
-        <p:txBody>
-          <a:bodyPr xmlns:a="http://schemas.openxmlformats.org/drawingml/2006/main"/>
-          <a:lstStyle xmlns:a="http://schemas.openxmlformats.org/drawingml/2006/main"/>
-          <a:p xmlns:a="http://schemas.openxmlformats.org/drawingml/2006/main"/>
-        </p:txBody>
-      </p:sp>
-      <p:sp>
-        <p:nvSpPr>
-          <p:cNvPr id="4" name="Slide Image Placeholder"/>
-          <p:cNvSpPr/>
-          <p:nvPr>
-            <p:ph type="sldImg" idx="2"/>
-          </p:nvPr>
-        </p:nvSpPr>
-        <p:spPr>
-          <a:prstGeom xmlns:a="http://schemas.openxmlformats.org/drawingml/2006/main" prst="rect">
-            <a:avLst/>
-          </a:prstGeom>
-        </p:spPr>
-        <p:txBody>
-          <a:bodyPr xmlns:a="http://schemas.openxmlformats.org/drawingml/2006/main"/>
-          <a:lstStyle xmlns:a="http://schemas.openxmlformats.org/drawingml/2006/main"/>
-          <a:p xmlns:a="http://schemas.openxmlformats.org/drawingml/2006/main"/>
-        </p:txBody>
-      </p:sp>
-      <p:sp>
-        <p:nvSpPr>
-          <p:cNvPr id="5" name="Notes Placeholder"/>
-          <p:cNvSpPr/>
-          <p:nvPr>
-            <p:ph type="body" sz="quarter" idx="3"/>
-          </p:nvPr>
-        </p:nvSpPr>
-        <p:spPr>
-          <a:prstGeom xmlns:a="http://schemas.openxmlformats.org/drawingml/2006/main" prst="rect">
-            <a:avLst/>
-          </a:prstGeom>
-        </p:spPr>
-        <p:txBody>
-          <a:bodyPr xmlns:a="http://schemas.openxmlformats.org/drawingml/2006/main"/>
-          <a:lstStyle xmlns:a="http://schemas.openxmlformats.org/drawingml/2006/main"/>
-          <a:p xmlns:a="http://schemas.openxmlformats.org/drawingml/2006/main"/>
-        </p:txBody>
-      </p:sp>
-      <p:sp>
-        <p:nvSpPr>
-          <p:cNvPr id="6" name="Footer Placeholder"/>
-          <p:cNvSpPr/>
-          <p:nvPr>
-            <p:ph type="ftr" sz="quarter" idx="4"/>
-          </p:nvPr>
-        </p:nvSpPr>
-        <p:spPr>
-          <a:prstGeom xmlns:a="http://schemas.openxmlformats.org/drawingml/2006/main" prst="rect">
-            <a:avLst/>
-          </a:prstGeom>
-        </p:spPr>
-        <p:txBody>
-          <a:bodyPr xmlns:a="http://schemas.openxmlformats.org/drawingml/2006/main"/>
-          <a:lstStyle xmlns:a="http://schemas.openxmlformats.org/drawingml/2006/main"/>
-          <a:p xmlns:a="http://schemas.openxmlformats.org/drawingml/2006/main"/>
-        </p:txBody>
-      </p:sp>
-      <p:sp>
-        <p:nvSpPr>
-          <p:cNvPr id="7" name="Slide Number Placeholder"/>
-          <p:cNvSpPr/>
-          <p:nvPr>
-            <p:ph type="sldNum" sz="quarter" idx="5"/>
-          </p:nvPr>
-        </p:nvSpPr>
-        <p:spPr>
-          <a:prstGeom xmlns:a="http://schemas.openxmlformats.org/drawingml/2006/main" prst="rect">
-            <a:avLst/>
-          </a:prstGeom>
-        </p:spPr>
-        <p:txBody>
-          <a:bodyPr xmlns:a="http://schemas.openxmlformats.org/drawingml/2006/main"/>
-          <a:lstStyle xmlns:a="http://schemas.openxmlformats.org/drawingml/2006/main"/>
-          <a:p xmlns:a="http://schemas.openxmlformats.org/drawingml/2006/main"/>
-        </p:txBody>
-      </p:sp>
-    </p:spTree>
-  </p:cSld>
-  <p:clrMap bg1="lt1" tx1="dk1" bg2="lt2" tx2="dk2" accent1="accent1" accent2="accent2" accent3="accent3" accent4="accent4" accent5="accent5" accent6="accent6" hlink="hlink" folHlink="folHlink"/>
-  <p:notesStyle>
-    <a:lvl1pPr xmlns:a="http://schemas.openxmlformats.org/drawingml/2006/main" marL="0" algn="l" defTabSz="914400" rtl="0" eaLnBrk="1" latinLnBrk="0" hangingPunct="1">
-      <a:defRPr sz="1200" kern="1200"/>
-    </a:lvl1pPr>
-  </p:notesStyle>
-</p:notesMaster>
-</file>
-
-<file path=ppt/notesMasters/theme/theme3.xml><?xml version="1.0" encoding="utf-8"?>
-<a:theme xmlns:a="http://schemas.openxmlformats.org/drawingml/2006/main" name="ChatGPT">
-  <a:themeElements>
-    <a:clrScheme name="ChatGPT">
-      <a:dk1>
-        <a:srgbClr val="000000"/>
-      </a:dk1>
-      <a:lt1>
-        <a:srgbClr val="FFFFFF"/>
-      </a:lt1>
-      <a:dk2>
-        <a:srgbClr val="0E2841"/>
-      </a:dk2>
-      <a:lt2>
-        <a:srgbClr val="E8E8E8"/>
-      </a:lt2>
-      <a:accent1>
-        <a:srgbClr val="156082"/>
-      </a:accent1>
-      <a:accent2>
-        <a:srgbClr val="E97132"/>
-      </a:accent2>
-      <a:accent3>
-        <a:srgbClr val="196B24"/>
-      </a:accent3>
-      <a:accent4>
-        <a:srgbClr val="0F9ED5"/>
-      </a:accent4>
-      <a:accent5>
-        <a:srgbClr val="A02B93"/>
-      </a:accent5>
-      <a:accent6>
-        <a:srgbClr val="4EA72E"/>
-      </a:accent6>
-      <a:hlink>
-        <a:srgbClr val="467886"/>
-      </a:hlink>
-      <a:folHlink>
-        <a:srgbClr val="96607D"/>
-      </a:folHlink>
-    </a:clrScheme>
-    <a:fontScheme name="">
-      <a:majorFont>
-        <a:latin typeface="Aptos"/>
-        <a:ea typeface=""/>
-        <a:cs typeface=""/>
-      </a:majorFont>
-      <a:minorFont>
-        <a:latin typeface="Aptos"/>
-        <a:ea typeface=""/>
-        <a:cs typeface=""/>
-      </a:minorFont>
-    </a:fontScheme>
-    <a:fmtScheme name="ChatGPT">
-      <a:fillStyleLst>
-        <a:solidFill>
-          <a:schemeClr val="phClr"/>
-        </a:solidFill>
-        <a:gradFill>
-          <a:gsLst>
-            <a:gs pos="0">
-              <a:schemeClr val="phClr">
-                <a:tint val="67000"/>
-                <a:lumMod val="110000"/>
-                <a:satMod val="105000"/>
-              </a:schemeClr>
-            </a:gs>
-            <a:gs pos="50000">
-              <a:schemeClr val="phClr">
-                <a:tint val="73000"/>
-                <a:lumMod val="105000"/>
-                <a:satMod val="103000"/>
-              </a:schemeClr>
-            </a:gs>
-            <a:gs pos="100000">
-              <a:schemeClr val="phClr">
-                <a:tint val="81000"/>
-                <a:lumMod val="105000"/>
-                <a:satMod val="109000"/>
-              </a:schemeClr>
-            </a:gs>
-          </a:gsLst>
-          <a:lin ang="5400000" scaled="0"/>
-        </a:gradFill>
-        <a:gradFill>
-          <a:gsLst>
-            <a:gs pos="0">
-              <a:schemeClr val="phClr">
-                <a:tint val="94000"/>
-                <a:lumMod val="102000"/>
-                <a:satMod val="103000"/>
-              </a:schemeClr>
-            </a:gs>
-            <a:gs pos="50000">
-              <a:schemeClr val="phClr">
-                <a:shade val="100000"/>
-                <a:lumMod val="100000"/>
-                <a:satMod val="110000"/>
-              </a:schemeClr>
-            </a:gs>
-            <a:gs pos="100000">
-              <a:schemeClr val="phClr">
-                <a:shade val="78000"/>
-                <a:lumMod val="99000"/>
-                <a:satMod val="120000"/>
-              </a:schemeClr>
-            </a:gs>
-          </a:gsLst>
-          <a:lin ang="5400000" scaled="0"/>
-        </a:gradFill>
-      </a:fillStyleLst>
-      <a:lnStyleLst>
-        <a:ln w="12700">
-          <a:solidFill>
-            <a:schemeClr val="phClr"/>
-          </a:solidFill>
-          <a:prstDash val="solid"/>
-        </a:ln>
-        <a:ln w="19050">
-          <a:solidFill>
-            <a:schemeClr val="phClr"/>
-          </a:solidFill>
-          <a:prstDash val="solid"/>
-        </a:ln>
-        <a:ln w="25400">
-          <a:solidFill>
-            <a:schemeClr val="phClr"/>
-          </a:solidFill>
-          <a:prstDash val="solid"/>
-        </a:ln>
-      </a:lnStyleLst>
-      <a:effectStyleLst>
-        <a:effectStyle>
-          <a:effectLst/>
-        </a:effectStyle>
-        <a:effectStyle>
-          <a:effectLst/>
-        </a:effectStyle>
-        <a:effectStyle>
-          <a:effectLst>
-            <a:outerShdw blurRad="57150" dist="19050" dir="5400000">
-              <a:srgbClr val="000000">
-                <a:alpha val="16000"/>
-              </a:srgbClr>
-            </a:outerShdw>
-          </a:effectLst>
-        </a:effectStyle>
-        <a:effectStyle>
-          <a:effectLst>
-            <a:outerShdw blurRad="19050" dist="9525" dir="5400000">
-              <a:srgbClr val="000000">
-                <a:alpha val="6000"/>
-              </a:srgbClr>
-            </a:outerShdw>
-          </a:effectLst>
-        </a:effectStyle>
-        <a:effectStyle>
-          <a:effectLst>
-            <a:outerShdw blurRad="28575" dist="9525" dir="5400000">
-              <a:srgbClr val="000000">
-                <a:alpha val="8000"/>
-              </a:srgbClr>
-            </a:outerShdw>
-          </a:effectLst>
-        </a:effectStyle>
-        <a:effectStyle>
-          <a:effectLst>
-            <a:outerShdw blurRad="57150" dist="19050" dir="5400000">
-              <a:srgbClr val="000000">
-                <a:alpha val="10000"/>
-              </a:srgbClr>
-            </a:outerShdw>
-          </a:effectLst>
-        </a:effectStyle>
-        <a:effectStyle>
-          <a:effectLst>
-            <a:outerShdw blurRad="114300" dist="38100" dir="5400000">
-              <a:srgbClr val="000000">
-                <a:alpha val="12000"/>
-              </a:srgbClr>
-            </a:outerShdw>
-          </a:effectLst>
-        </a:effectStyle>
-        <a:effectStyle>
-          <a:effectLst>
-            <a:outerShdw blurRad="171450" dist="57150" dir="5400000">
-              <a:srgbClr val="000000">
-                <a:alpha val="16000"/>
-              </a:srgbClr>
-            </a:outerShdw>
-          </a:effectLst>
-        </a:effectStyle>
-        <a:effectStyle>
-          <a:effectLst>
-            <a:outerShdw blurRad="266700" dist="95250" dir="5400000">
-              <a:srgbClr val="000000">
-                <a:alpha val="24000"/>
-              </a:srgbClr>
-            </a:outerShdw>
-          </a:effectLst>
-        </a:effectStyle>
-      </a:effectStyleLst>
-      <a:bgFillStyleLst>
-        <a:solidFill>
-          <a:schemeClr val="phClr"/>
-        </a:solidFill>
-        <a:solidFill>
-          <a:schemeClr val="phClr">
-            <a:tint val="95000"/>
-            <a:satMod val="170000"/>
-          </a:schemeClr>
-        </a:solidFill>
-        <a:gradFill>
-          <a:gsLst>
-            <a:gs pos="0">
-              <a:schemeClr val="phClr">
-                <a:tint val="93000"/>
-                <a:shade val="98000"/>
-                <a:lumMod val="102000"/>
-                <a:satMod val="150000"/>
-              </a:schemeClr>
-            </a:gs>
-            <a:gs pos="50000">
-              <a:schemeClr val="phClr">
-                <a:tint val="98000"/>
-                <a:shade val="90000"/>
-                <a:lumMod val="103000"/>
-                <a:satMod val="130000"/>
-              </a:schemeClr>
-            </a:gs>
-            <a:gs pos="100000">
-              <a:schemeClr val="phClr">
-                <a:shade val="63000"/>
-                <a:satMod val="120000"/>
-              </a:schemeClr>
-            </a:gs>
-          </a:gsLst>
-          <a:lin ang="5400000" scaled="0"/>
-        </a:gradFill>
-      </a:bgFillStyleLst>
-    </a:fmtScheme>
-  </a:themeElements>
-</a:theme>
-</file>
-
-<file path=ppt/notesSlides/notesSlide1.xml><?xml version="1.0" encoding="utf-8"?>
-<p:notes xmlns:p="http://schemas.openxmlformats.org/presentationml/2006/main">
-  <p:cSld>
-    <p:spTree>
-      <p:nvGrpSpPr>
-        <p:cNvPr id="1" name=""/>
-        <p:cNvGrpSpPr/>
-        <p:nvPr/>
-      </p:nvGrpSpPr>
-      <p:grpSpPr>
-        <a:xfrm xmlns:a="http://schemas.openxmlformats.org/drawingml/2006/main"/>
-      </p:grpSpPr>
-      <p:sp>
-        <p:nvSpPr>
-          <p:cNvPr id="2" name="Slide Image Placeholder 1"/>
-          <p:cNvSpPr>
-            <a:spLocks xmlns:a="http://schemas.openxmlformats.org/drawingml/2006/main" noGrp="1"/>
-          </p:cNvSpPr>
-          <p:nvPr>
-            <p:ph type="sldImg" idx="0"/>
-          </p:nvPr>
-        </p:nvSpPr>
-        <p:spPr/>
-      </p:sp>
-      <p:sp>
-        <p:nvSpPr>
-          <p:cNvPr id="3" name="Notes Placeholder 2"/>
-          <p:cNvSpPr>
-            <a:spLocks xmlns:a="http://schemas.openxmlformats.org/drawingml/2006/main" noGrp="1"/>
-          </p:cNvSpPr>
-          <p:nvPr>
-            <p:ph type="body" idx="1"/>
-          </p:nvPr>
-        </p:nvSpPr>
-        <p:spPr/>
-        <p:txBody>
-          <a:bodyPr xmlns:a="http://schemas.openxmlformats.org/drawingml/2006/main"/>
-          <a:lstStyle xmlns:a="http://schemas.openxmlformats.org/drawingml/2006/main"/>
-          <a:p xmlns:a="http://schemas.openxmlformats.org/drawingml/2006/main">
-            <a:r>
-              <a:t>Hello everyone. My Week One project is Prism, a local web application that helps marketing analysts check claims about campaign performance.</a:t>
-            </a:r>
-          </a:p>
-          <a:p xmlns:a="http://schemas.openxmlformats.org/drawingml/2006/main">
-            <a:r>
-              <a:t/>
-            </a:r>
-          </a:p>
-          <a:p xmlns:a="http://schemas.openxmlformats.org/drawingml/2006/main">
-            <a:r>
-              <a:t>The problem is that an overall conversion rate can improve even when individual customer groups perform worse. If a team relies only on that average, it may increase its budget without understanding what changed.</a:t>
-            </a:r>
-          </a:p>
-          <a:p xmlns:a="http://schemas.openxmlformats.org/drawingml/2006/main">
-            <a:r>
-              <a:t/>
-            </a:r>
-          </a:p>
-          <a:p xmlns:a="http://schemas.openxmlformats.org/drawingml/2006/main">
-            <a:r>
-              <a:t>Prism compares the overall result with each customer group, shows changes in audience mix, and explains whether a selected claim is supported by the data.</a:t>
-            </a:r>
-          </a:p>
-        </p:txBody>
-      </p:sp>
-      <p:sp>
-        <p:nvSpPr>
-          <p:cNvPr id="4" name="Slide Number Placeholder 3"/>
-          <p:cNvSpPr>
-            <a:spLocks xmlns:a="http://schemas.openxmlformats.org/drawingml/2006/main" noGrp="1"/>
-          </p:cNvSpPr>
-          <p:nvPr>
-            <p:ph type="sldNum" idx="5"/>
-          </p:nvPr>
-        </p:nvSpPr>
-        <p:spPr/>
-        <p:txBody>
-          <a:bodyPr xmlns:a="http://schemas.openxmlformats.org/drawingml/2006/main"/>
-          <a:lstStyle xmlns:a="http://schemas.openxmlformats.org/drawingml/2006/main"/>
-          <a:p xmlns:a="http://schemas.openxmlformats.org/drawingml/2006/main"/>
-        </p:txBody>
-      </p:sp>
-    </p:spTree>
-  </p:cSld>
-  <p:clrMapOvr>
-    <a:masterClrMapping xmlns:a="http://schemas.openxmlformats.org/drawingml/2006/main"/>
-  </p:clrMapOvr>
-</p:notes>
-</file>
-
-<file path=ppt/notesSlides/notesSlide2.xml><?xml version="1.0" encoding="utf-8"?>
-<p:notes xmlns:p="http://schemas.openxmlformats.org/presentationml/2006/main">
-  <p:cSld>
-    <p:spTree>
-      <p:nvGrpSpPr>
-        <p:cNvPr id="1" name=""/>
-        <p:cNvGrpSpPr/>
-        <p:nvPr/>
-      </p:nvGrpSpPr>
-      <p:grpSpPr>
-        <a:xfrm xmlns:a="http://schemas.openxmlformats.org/drawingml/2006/main"/>
-      </p:grpSpPr>
-      <p:sp>
-        <p:nvSpPr>
-          <p:cNvPr id="2" name="Slide Image Placeholder 1"/>
-          <p:cNvSpPr>
-            <a:spLocks xmlns:a="http://schemas.openxmlformats.org/drawingml/2006/main" noGrp="1"/>
-          </p:cNvSpPr>
-          <p:nvPr>
-            <p:ph type="sldImg" idx="0"/>
-          </p:nvPr>
-        </p:nvSpPr>
-        <p:spPr/>
-      </p:sp>
-      <p:sp>
-        <p:nvSpPr>
-          <p:cNvPr id="3" name="Notes Placeholder 2"/>
-          <p:cNvSpPr>
-            <a:spLocks xmlns:a="http://schemas.openxmlformats.org/drawingml/2006/main" noGrp="1"/>
-          </p:cNvSpPr>
-          <p:nvPr>
-            <p:ph type="body" idx="1"/>
-          </p:nvPr>
-        </p:nvSpPr>
-        <p:spPr/>
-        <p:txBody>
-          <a:bodyPr xmlns:a="http://schemas.openxmlformats.org/drawingml/2006/main"/>
-          <a:lstStyle xmlns:a="http://schemas.openxmlformats.org/drawingml/2006/main"/>
-          <a:p xmlns:a="http://schemas.openxmlformats.org/drawingml/2006/main">
-            <a:r>
-              <a:t>Here is the story behind the demo. A marketing manager sees conversion rise from 20 percent to 45.6 percent and considers increasing the budget.</a:t>
-            </a:r>
-          </a:p>
-          <a:p xmlns:a="http://schemas.openxmlformats.org/drawingml/2006/main">
-            <a:r>
-              <a:t/>
-            </a:r>
-          </a:p>
-          <a:p xmlns:a="http://schemas.openxmlformats.org/drawingml/2006/main">
-            <a:r>
-              <a:t>But in our synthetic dataset, new customers fall from 10 to 8 percent, and returning customers fall from 60 to 55 percent. Both groups decline.</a:t>
-            </a:r>
-          </a:p>
-          <a:p xmlns:a="http://schemas.openxmlformats.org/drawingml/2006/main">
-            <a:r>
-              <a:t/>
-            </a:r>
-          </a:p>
-          <a:p xmlns:a="http://schemas.openxmlformats.org/drawingml/2006/main">
-            <a:r>
-              <a:t>The audience has shifted toward returning customers, who already convert more often. So the overall increase is real, but it does not mean every group improved or that the campaign caused the change. Prism makes that distinction visible.</a:t>
-            </a:r>
-          </a:p>
-          <a:p xmlns:a="http://schemas.openxmlformats.org/drawingml/2006/main">
-            <a:r>
-              <a:t/>
-            </a:r>
-          </a:p>
-          <a:p xmlns:a="http://schemas.openxmlformats.org/drawingml/2006/main">
-            <a:r>
-              <a:t>Data: Prism-Campaign-Test.csv, synthetic demonstration data.</a:t>
-            </a:r>
-          </a:p>
-        </p:txBody>
-      </p:sp>
-      <p:sp>
-        <p:nvSpPr>
-          <p:cNvPr id="4" name="Slide Number Placeholder 3"/>
-          <p:cNvSpPr>
-            <a:spLocks xmlns:a="http://schemas.openxmlformats.org/drawingml/2006/main" noGrp="1"/>
-          </p:cNvSpPr>
-          <p:nvPr>
-            <p:ph type="sldNum" idx="5"/>
-          </p:nvPr>
-        </p:nvSpPr>
-        <p:spPr/>
-        <p:txBody>
-          <a:bodyPr xmlns:a="http://schemas.openxmlformats.org/drawingml/2006/main"/>
-          <a:lstStyle xmlns:a="http://schemas.openxmlformats.org/drawingml/2006/main"/>
-          <a:p xmlns:a="http://schemas.openxmlformats.org/drawingml/2006/main"/>
-        </p:txBody>
-      </p:sp>
-    </p:spTree>
-  </p:cSld>
-  <p:clrMapOvr>
-    <a:masterClrMapping xmlns:a="http://schemas.openxmlformats.org/drawingml/2006/main"/>
-  </p:clrMapOvr>
-</p:notes>
-</file>
-
-<file path=ppt/notesSlides/notesSlide3.xml><?xml version="1.0" encoding="utf-8"?>
-<p:notes xmlns:p="http://schemas.openxmlformats.org/presentationml/2006/main">
-  <p:cSld>
-    <p:spTree>
-      <p:nvGrpSpPr>
-        <p:cNvPr id="1" name=""/>
-        <p:cNvGrpSpPr/>
-        <p:nvPr/>
-      </p:nvGrpSpPr>
-      <p:grpSpPr>
-        <a:xfrm xmlns:a="http://schemas.openxmlformats.org/drawingml/2006/main"/>
-      </p:grpSpPr>
-      <p:sp>
-        <p:nvSpPr>
-          <p:cNvPr id="2" name="Slide Image Placeholder 1"/>
-          <p:cNvSpPr>
-            <a:spLocks xmlns:a="http://schemas.openxmlformats.org/drawingml/2006/main" noGrp="1"/>
-          </p:cNvSpPr>
-          <p:nvPr>
-            <p:ph type="sldImg" idx="0"/>
-          </p:nvPr>
-        </p:nvSpPr>
-        <p:spPr/>
-      </p:sp>
-      <p:sp>
-        <p:nvSpPr>
-          <p:cNvPr id="3" name="Notes Placeholder 2"/>
-          <p:cNvSpPr>
-            <a:spLocks xmlns:a="http://schemas.openxmlformats.org/drawingml/2006/main" noGrp="1"/>
-          </p:cNvSpPr>
-          <p:nvPr>
-            <p:ph type="body" idx="1"/>
-          </p:nvPr>
-        </p:nvSpPr>
-        <p:spPr/>
-        <p:txBody>
-          <a:bodyPr xmlns:a="http://schemas.openxmlformats.org/drawingml/2006/main"/>
-          <a:lstStyle xmlns:a="http://schemas.openxmlformats.org/drawingml/2006/main"/>
-          <a:p xmlns:a="http://schemas.openxmlformats.org/drawingml/2006/main">
-            <a:r>
-              <a:t>Prism runs entirely in the browser. A CSV or sample dataset enters validation, then the app calculates overall rates, group rates, and a comparison that holds the audience mix constant.</a:t>
-            </a:r>
-          </a:p>
-          <a:p xmlns:a="http://schemas.openxmlformats.org/drawingml/2006/main">
-            <a:r>
-              <a:t/>
-            </a:r>
-          </a:p>
-          <a:p xmlns:a="http://schemas.openxmlformats.org/drawingml/2006/main">
-            <a:r>
-              <a:t>Explicit rules check the selected claim, and the interface shows the evidence. Sandbox edits reuse those calculations. The evaluation page checks the rules against twelve fixed reference cases.</a:t>
-            </a:r>
-          </a:p>
-          <a:p xmlns:a="http://schemas.openxmlformats.org/drawingml/2006/main">
-            <a:r>
-              <a:t/>
-            </a:r>
-          </a:p>
-          <a:p xmlns:a="http://schemas.openxmlformats.org/drawingml/2006/main">
-            <a:r>
-              <a:t>I used Codex to help build and refine the application. It needs no paid APIs, and its answers come from calculations rather than a live AI model.</a:t>
-            </a:r>
-          </a:p>
-          <a:p xmlns:a="http://schemas.openxmlformats.org/drawingml/2006/main">
-            <a:r>
-              <a:t/>
-            </a:r>
-          </a:p>
-          <a:p xmlns:a="http://schemas.openxmlformats.org/drawingml/2006/main">
-            <a:r>
-              <a:t>Now I will show you the investigation, change the inputs, and test the results.</a:t>
-            </a:r>
-          </a:p>
-        </p:txBody>
-      </p:sp>
-      <p:sp>
-        <p:nvSpPr>
-          <p:cNvPr id="4" name="Slide Number Placeholder 3"/>
-          <p:cNvSpPr>
-            <a:spLocks xmlns:a="http://schemas.openxmlformats.org/drawingml/2006/main" noGrp="1"/>
-          </p:cNvSpPr>
-          <p:nvPr>
-            <p:ph type="sldNum" idx="5"/>
-          </p:nvPr>
-        </p:nvSpPr>
-        <p:spPr/>
-        <p:txBody>
-          <a:bodyPr xmlns:a="http://schemas.openxmlformats.org/drawingml/2006/main"/>
-          <a:lstStyle xmlns:a="http://schemas.openxmlformats.org/drawingml/2006/main"/>
-          <a:p xmlns:a="http://schemas.openxmlformats.org/drawingml/2006/main"/>
-        </p:txBody>
-      </p:sp>
-    </p:spTree>
-  </p:cSld>
-  <p:clrMapOvr>
-    <a:masterClrMapping xmlns:a="http://schemas.openxmlformats.org/drawingml/2006/main"/>
-  </p:clrMapOvr>
-</p:notes>
+<ns0:presentation xmlns:ns0="http://schemas.openxmlformats.org/presentationml/2006/main" xmlns:ns1="http://schemas.openxmlformats.org/officeDocument/2006/relationships">
+  <ns0:sldMasterIdLst>
+    <ns0:sldMasterId id="2147483648" ns1:id="Rcc1a760a4666491c"/>
+  </ns0:sldMasterIdLst>
+  <ns0:sldIdLst>
+    <ns0:sldId id="256" ns1:id="Rcd3cad99104e4dd7"/>
+    <ns0:sldId id="257" ns1:id="Rd2c363007ceb4775"/>
+    <ns0:sldId id="258" ns1:id="R301696bd72ec4f11"/>
+  </ns0:sldIdLst>
+  <ns0:sldSz cx="12192000" cy="6858000"/>
+  <ns0:notesSz cx="6858000" cy="9144000"/>
+</ns0:presentation>
 </file>
 
 <file path=ppt/slideLayouts/slideLayout1.xml><?xml version="1.0" encoding="utf-8"?>

</xml_diff>